<commit_message>
Actualizar presentación del proyecto (evidencias grupales e individuales)
Co-Authored-By: Claude Sonnet 5 <noreply@anthropic.com>
</commit_message>
<xml_diff>
--- a/Fase_1/Evidencias_Grupales/Presentacion Proyecto.pptx
+++ b/Fase_1/Evidencias_Grupales/Presentacion Proyecto.pptx
@@ -994,7 +994,7 @@
   <p:cSld>
     <p:spTree>
       <p:nvGrpSpPr>
-        <p:cNvPr id="172" name="Shape 172"/>
+        <p:cNvPr id="173" name="Shape 173"/>
         <p:cNvGrpSpPr/>
         <p:nvPr/>
       </p:nvGrpSpPr>
@@ -1008,7 +1008,7 @@
       </p:grpSpPr>
       <p:sp>
         <p:nvSpPr>
-          <p:cNvPr id="173" name="Google Shape;173;g3f8aee16b2b_1_409:notes"/>
+          <p:cNvPr id="174" name="Google Shape;174;g3f8aee16b2b_1_409:notes"/>
           <p:cNvSpPr/>
           <p:nvPr>
             <p:ph idx="2" type="sldImg"/>
@@ -1053,7 +1053,7 @@
       </p:sp>
       <p:sp>
         <p:nvSpPr>
-          <p:cNvPr id="174" name="Google Shape;174;g3f8aee16b2b_1_409:notes"/>
+          <p:cNvPr id="175" name="Google Shape;175;g3f8aee16b2b_1_409:notes"/>
           <p:cNvSpPr txBox="1"/>
           <p:nvPr>
             <p:ph idx="1" type="body"/>
@@ -1111,7 +1111,7 @@
   <p:cSld>
     <p:spTree>
       <p:nvGrpSpPr>
-        <p:cNvPr id="186" name="Shape 186"/>
+        <p:cNvPr id="187" name="Shape 187"/>
         <p:cNvGrpSpPr/>
         <p:nvPr/>
       </p:nvGrpSpPr>
@@ -1125,7 +1125,7 @@
       </p:grpSpPr>
       <p:sp>
         <p:nvSpPr>
-          <p:cNvPr id="187" name="Google Shape;187;g3f4164cdfdb_0_15:notes"/>
+          <p:cNvPr id="188" name="Google Shape;188;g3f4164cdfdb_0_15:notes"/>
           <p:cNvSpPr/>
           <p:nvPr>
             <p:ph idx="2" type="sldImg"/>
@@ -1170,7 +1170,7 @@
       </p:sp>
       <p:sp>
         <p:nvSpPr>
-          <p:cNvPr id="188" name="Google Shape;188;g3f4164cdfdb_0_15:notes"/>
+          <p:cNvPr id="189" name="Google Shape;189;g3f4164cdfdb_0_15:notes"/>
           <p:cNvSpPr txBox="1"/>
           <p:nvPr>
             <p:ph idx="1" type="body"/>
@@ -1213,7 +1213,7 @@
       </p:sp>
       <p:sp>
         <p:nvSpPr>
-          <p:cNvPr id="189" name="Google Shape;189;g3f4164cdfdb_0_15:notes"/>
+          <p:cNvPr id="190" name="Google Shape;190;g3f4164cdfdb_0_15:notes"/>
           <p:cNvSpPr txBox="1"/>
           <p:nvPr>
             <p:ph idx="12" type="sldNum"/>
@@ -1268,7 +1268,7 @@
   <p:cSld>
     <p:spTree>
       <p:nvGrpSpPr>
-        <p:cNvPr id="66" name="Shape 66"/>
+        <p:cNvPr id="67" name="Shape 67"/>
         <p:cNvGrpSpPr/>
         <p:nvPr/>
       </p:nvGrpSpPr>
@@ -1282,7 +1282,7 @@
       </p:grpSpPr>
       <p:sp>
         <p:nvSpPr>
-          <p:cNvPr id="67" name="Google Shape;67;p2:notes"/>
+          <p:cNvPr id="68" name="Google Shape;68;p2:notes"/>
           <p:cNvSpPr/>
           <p:nvPr>
             <p:ph idx="2" type="sldImg"/>
@@ -1327,7 +1327,7 @@
       </p:sp>
       <p:sp>
         <p:nvSpPr>
-          <p:cNvPr id="68" name="Google Shape;68;p2:notes"/>
+          <p:cNvPr id="69" name="Google Shape;69;p2:notes"/>
           <p:cNvSpPr txBox="1"/>
           <p:nvPr>
             <p:ph idx="1" type="body"/>
@@ -1385,7 +1385,7 @@
   <p:cSld>
     <p:spTree>
       <p:nvGrpSpPr>
-        <p:cNvPr id="72" name="Shape 72"/>
+        <p:cNvPr id="73" name="Shape 73"/>
         <p:cNvGrpSpPr/>
         <p:nvPr/>
       </p:nvGrpSpPr>
@@ -1399,7 +1399,7 @@
       </p:grpSpPr>
       <p:sp>
         <p:nvSpPr>
-          <p:cNvPr id="73" name="Google Shape;73;g3f8aee16b2b_1_91:notes"/>
+          <p:cNvPr id="74" name="Google Shape;74;g3f8aee16b2b_1_91:notes"/>
           <p:cNvSpPr/>
           <p:nvPr>
             <p:ph idx="2" type="sldImg"/>
@@ -1444,7 +1444,7 @@
       </p:sp>
       <p:sp>
         <p:nvSpPr>
-          <p:cNvPr id="74" name="Google Shape;74;g3f8aee16b2b_1_91:notes"/>
+          <p:cNvPr id="75" name="Google Shape;75;g3f8aee16b2b_1_91:notes"/>
           <p:cNvSpPr txBox="1"/>
           <p:nvPr>
             <p:ph idx="1" type="body"/>
@@ -1502,7 +1502,7 @@
   <p:cSld>
     <p:spTree>
       <p:nvGrpSpPr>
-        <p:cNvPr id="91" name="Shape 91"/>
+        <p:cNvPr id="92" name="Shape 92"/>
         <p:cNvGrpSpPr/>
         <p:nvPr/>
       </p:nvGrpSpPr>
@@ -1516,7 +1516,7 @@
       </p:grpSpPr>
       <p:sp>
         <p:nvSpPr>
-          <p:cNvPr id="92" name="Google Shape;92;g3f8aee16b2b_1_156:notes"/>
+          <p:cNvPr id="93" name="Google Shape;93;g3f8aee16b2b_1_156:notes"/>
           <p:cNvSpPr/>
           <p:nvPr>
             <p:ph idx="2" type="sldImg"/>
@@ -1561,7 +1561,7 @@
       </p:sp>
       <p:sp>
         <p:nvSpPr>
-          <p:cNvPr id="93" name="Google Shape;93;g3f8aee16b2b_1_156:notes"/>
+          <p:cNvPr id="94" name="Google Shape;94;g3f8aee16b2b_1_156:notes"/>
           <p:cNvSpPr txBox="1"/>
           <p:nvPr>
             <p:ph idx="1" type="body"/>
@@ -1619,7 +1619,7 @@
   <p:cSld>
     <p:spTree>
       <p:nvGrpSpPr>
-        <p:cNvPr id="120" name="Shape 120"/>
+        <p:cNvPr id="121" name="Shape 121"/>
         <p:cNvGrpSpPr/>
         <p:nvPr/>
       </p:nvGrpSpPr>
@@ -1633,7 +1633,7 @@
       </p:grpSpPr>
       <p:sp>
         <p:nvSpPr>
-          <p:cNvPr id="121" name="Google Shape;121;g3f8aee16b2b_1_230:notes"/>
+          <p:cNvPr id="122" name="Google Shape;122;g3f8aee16b2b_1_230:notes"/>
           <p:cNvSpPr/>
           <p:nvPr>
             <p:ph idx="2" type="sldImg"/>
@@ -1678,7 +1678,7 @@
       </p:sp>
       <p:sp>
         <p:nvSpPr>
-          <p:cNvPr id="122" name="Google Shape;122;g3f8aee16b2b_1_230:notes"/>
+          <p:cNvPr id="123" name="Google Shape;123;g3f8aee16b2b_1_230:notes"/>
           <p:cNvSpPr txBox="1"/>
           <p:nvPr>
             <p:ph idx="1" type="body"/>
@@ -1736,7 +1736,7 @@
   <p:cSld>
     <p:spTree>
       <p:nvGrpSpPr>
-        <p:cNvPr id="135" name="Shape 135"/>
+        <p:cNvPr id="136" name="Shape 136"/>
         <p:cNvGrpSpPr/>
         <p:nvPr/>
       </p:nvGrpSpPr>
@@ -1750,7 +1750,7 @@
       </p:grpSpPr>
       <p:sp>
         <p:nvSpPr>
-          <p:cNvPr id="136" name="Google Shape;136;p6:notes"/>
+          <p:cNvPr id="137" name="Google Shape;137;p6:notes"/>
           <p:cNvSpPr/>
           <p:nvPr>
             <p:ph idx="2" type="sldImg"/>
@@ -1795,7 +1795,7 @@
       </p:sp>
       <p:sp>
         <p:nvSpPr>
-          <p:cNvPr id="137" name="Google Shape;137;p6:notes"/>
+          <p:cNvPr id="138" name="Google Shape;138;p6:notes"/>
           <p:cNvSpPr txBox="1"/>
           <p:nvPr>
             <p:ph idx="1" type="body"/>
@@ -1853,7 +1853,7 @@
   <p:cSld>
     <p:spTree>
       <p:nvGrpSpPr>
-        <p:cNvPr id="141" name="Shape 141"/>
+        <p:cNvPr id="142" name="Shape 142"/>
         <p:cNvGrpSpPr/>
         <p:nvPr/>
       </p:nvGrpSpPr>
@@ -1867,7 +1867,7 @@
       </p:grpSpPr>
       <p:sp>
         <p:nvSpPr>
-          <p:cNvPr id="142" name="Google Shape;142;g3f8aee16b2b_1_293:notes"/>
+          <p:cNvPr id="143" name="Google Shape;143;g3f8aee16b2b_1_293:notes"/>
           <p:cNvSpPr/>
           <p:nvPr>
             <p:ph idx="2" type="sldImg"/>
@@ -1912,7 +1912,7 @@
       </p:sp>
       <p:sp>
         <p:nvSpPr>
-          <p:cNvPr id="143" name="Google Shape;143;g3f8aee16b2b_1_293:notes"/>
+          <p:cNvPr id="144" name="Google Shape;144;g3f8aee16b2b_1_293:notes"/>
           <p:cNvSpPr txBox="1"/>
           <p:nvPr>
             <p:ph idx="1" type="body"/>
@@ -1970,7 +1970,7 @@
   <p:cSld>
     <p:spTree>
       <p:nvGrpSpPr>
-        <p:cNvPr id="151" name="Shape 151"/>
+        <p:cNvPr id="152" name="Shape 152"/>
         <p:cNvGrpSpPr/>
         <p:nvPr/>
       </p:nvGrpSpPr>
@@ -1984,7 +1984,7 @@
       </p:grpSpPr>
       <p:sp>
         <p:nvSpPr>
-          <p:cNvPr id="152" name="Google Shape;152;g3f8aee16b2b_1_349:notes"/>
+          <p:cNvPr id="153" name="Google Shape;153;g3f8aee16b2b_1_349:notes"/>
           <p:cNvSpPr/>
           <p:nvPr>
             <p:ph idx="2" type="sldImg"/>
@@ -2029,7 +2029,7 @@
       </p:sp>
       <p:sp>
         <p:nvSpPr>
-          <p:cNvPr id="153" name="Google Shape;153;g3f8aee16b2b_1_349:notes"/>
+          <p:cNvPr id="154" name="Google Shape;154;g3f8aee16b2b_1_349:notes"/>
           <p:cNvSpPr txBox="1"/>
           <p:nvPr>
             <p:ph idx="1" type="body"/>
@@ -2087,7 +2087,7 @@
   <p:cSld>
     <p:spTree>
       <p:nvGrpSpPr>
-        <p:cNvPr id="166" name="Shape 166"/>
+        <p:cNvPr id="167" name="Shape 167"/>
         <p:cNvGrpSpPr/>
         <p:nvPr/>
       </p:nvGrpSpPr>
@@ -2101,7 +2101,7 @@
       </p:grpSpPr>
       <p:sp>
         <p:nvSpPr>
-          <p:cNvPr id="167" name="Google Shape;167;p9:notes"/>
+          <p:cNvPr id="168" name="Google Shape;168;p9:notes"/>
           <p:cNvSpPr/>
           <p:nvPr>
             <p:ph idx="2" type="sldImg"/>
@@ -2146,7 +2146,7 @@
       </p:sp>
       <p:sp>
         <p:nvSpPr>
-          <p:cNvPr id="168" name="Google Shape;168;p9:notes"/>
+          <p:cNvPr id="169" name="Google Shape;169;p9:notes"/>
           <p:cNvSpPr txBox="1"/>
           <p:nvPr>
             <p:ph idx="1" type="body"/>
@@ -11292,6 +11292,34 @@
           </p:txBody>
         </p:sp>
       </p:grpSp>
+      <p:pic>
+        <p:nvPicPr>
+          <p:cNvPr descr="http://www.duoc.cl/normasgraficas/normasgraficas/marca-duoc/6logo-fondo-transparente/fondo-transparente.png" id="66" name="Google Shape;66;p16"/>
+          <p:cNvPicPr preferRelativeResize="0"/>
+          <p:nvPr/>
+        </p:nvPicPr>
+        <p:blipFill>
+          <a:blip r:embed="rId3">
+            <a:alphaModFix/>
+          </a:blip>
+          <a:stretch>
+            <a:fillRect/>
+          </a:stretch>
+        </p:blipFill>
+        <p:spPr>
+          <a:xfrm>
+            <a:off x="6786525" y="205225"/>
+            <a:ext cx="2000250" cy="428625"/>
+          </a:xfrm>
+          <a:prstGeom prst="rect">
+            <a:avLst/>
+          </a:prstGeom>
+          <a:noFill/>
+          <a:ln>
+            <a:noFill/>
+          </a:ln>
+        </p:spPr>
+      </p:pic>
     </p:spTree>
   </p:cSld>
   <p:clrMapOvr>
@@ -11305,7 +11333,7 @@
   <p:cSld>
     <p:spTree>
       <p:nvGrpSpPr>
-        <p:cNvPr id="175" name="Shape 175"/>
+        <p:cNvPr id="176" name="Shape 176"/>
         <p:cNvGrpSpPr/>
         <p:nvPr/>
       </p:nvGrpSpPr>
@@ -11319,7 +11347,7 @@
       </p:grpSpPr>
       <p:sp>
         <p:nvSpPr>
-          <p:cNvPr id="176" name="Google Shape;176;p25"/>
+          <p:cNvPr id="177" name="Google Shape;177;p25"/>
           <p:cNvSpPr txBox="1"/>
           <p:nvPr>
             <p:ph type="title"/>
@@ -11383,7 +11411,7 @@
       </p:sp>
       <p:sp>
         <p:nvSpPr>
-          <p:cNvPr id="177" name="Google Shape;177;p25"/>
+          <p:cNvPr id="178" name="Google Shape;178;p25"/>
           <p:cNvSpPr txBox="1"/>
           <p:nvPr/>
         </p:nvSpPr>
@@ -11445,7 +11473,7 @@
       </p:sp>
       <p:grpSp>
         <p:nvGrpSpPr>
-          <p:cNvPr id="178" name="Google Shape;178;p25"/>
+          <p:cNvPr id="179" name="Google Shape;179;p25"/>
           <p:cNvGrpSpPr/>
           <p:nvPr/>
         </p:nvGrpSpPr>
@@ -11459,7 +11487,7 @@
         </p:grpSpPr>
         <p:sp>
           <p:nvSpPr>
-            <p:cNvPr id="179" name="Google Shape;179;p25"/>
+            <p:cNvPr id="180" name="Google Shape;180;p25"/>
             <p:cNvSpPr/>
             <p:nvPr/>
           </p:nvSpPr>
@@ -11510,7 +11538,7 @@
         </p:sp>
         <p:sp>
           <p:nvSpPr>
-            <p:cNvPr id="180" name="Google Shape;180;p25"/>
+            <p:cNvPr id="181" name="Google Shape;181;p25"/>
             <p:cNvSpPr/>
             <p:nvPr/>
           </p:nvSpPr>
@@ -11555,7 +11583,7 @@
         </p:sp>
         <p:sp>
           <p:nvSpPr>
-            <p:cNvPr id="181" name="Google Shape;181;p25"/>
+            <p:cNvPr id="182" name="Google Shape;182;p25"/>
             <p:cNvSpPr txBox="1"/>
             <p:nvPr/>
           </p:nvSpPr>
@@ -11761,7 +11789,7 @@
       </p:grpSp>
       <p:grpSp>
         <p:nvGrpSpPr>
-          <p:cNvPr id="182" name="Google Shape;182;p25"/>
+          <p:cNvPr id="183" name="Google Shape;183;p25"/>
           <p:cNvGrpSpPr/>
           <p:nvPr/>
         </p:nvGrpSpPr>
@@ -11775,7 +11803,7 @@
         </p:grpSpPr>
         <p:sp>
           <p:nvSpPr>
-            <p:cNvPr id="183" name="Google Shape;183;p25"/>
+            <p:cNvPr id="184" name="Google Shape;184;p25"/>
             <p:cNvSpPr/>
             <p:nvPr/>
           </p:nvSpPr>
@@ -11826,7 +11854,7 @@
         </p:sp>
         <p:sp>
           <p:nvSpPr>
-            <p:cNvPr id="184" name="Google Shape;184;p25"/>
+            <p:cNvPr id="185" name="Google Shape;185;p25"/>
             <p:cNvSpPr/>
             <p:nvPr/>
           </p:nvSpPr>
@@ -11871,7 +11899,7 @@
         </p:sp>
         <p:sp>
           <p:nvSpPr>
-            <p:cNvPr id="185" name="Google Shape;185;p25"/>
+            <p:cNvPr id="186" name="Google Shape;186;p25"/>
             <p:cNvSpPr txBox="1"/>
             <p:nvPr/>
           </p:nvSpPr>
@@ -12095,7 +12123,7 @@
     </p:bg>
     <p:spTree>
       <p:nvGrpSpPr>
-        <p:cNvPr id="190" name="Shape 190"/>
+        <p:cNvPr id="191" name="Shape 191"/>
         <p:cNvGrpSpPr/>
         <p:nvPr/>
       </p:nvGrpSpPr>
@@ -12109,7 +12137,7 @@
       </p:grpSpPr>
       <p:sp>
         <p:nvSpPr>
-          <p:cNvPr id="191" name="Google Shape;191;p26"/>
+          <p:cNvPr id="192" name="Google Shape;192;p26"/>
           <p:cNvSpPr/>
           <p:nvPr/>
         </p:nvSpPr>
@@ -12156,13 +12184,13 @@
       </p:sp>
       <p:sp>
         <p:nvSpPr>
-          <p:cNvPr id="192" name="Google Shape;192;p26"/>
+          <p:cNvPr id="193" name="Google Shape;193;p26"/>
           <p:cNvSpPr/>
           <p:nvPr/>
         </p:nvSpPr>
         <p:spPr>
           <a:xfrm>
-            <a:off x="0" y="0"/>
+            <a:off x="0" y="-22234"/>
             <a:ext cx="2880600" cy="5173800"/>
           </a:xfrm>
           <a:prstGeom prst="rect">
@@ -12199,7 +12227,7 @@
       </p:sp>
       <p:sp>
         <p:nvSpPr>
-          <p:cNvPr id="193" name="Google Shape;193;p26"/>
+          <p:cNvPr id="194" name="Google Shape;194;p26"/>
           <p:cNvSpPr/>
           <p:nvPr/>
         </p:nvSpPr>
@@ -12242,7 +12270,7 @@
       </p:sp>
       <p:sp>
         <p:nvSpPr>
-          <p:cNvPr id="194" name="Google Shape;194;p26"/>
+          <p:cNvPr id="195" name="Google Shape;195;p26"/>
           <p:cNvSpPr txBox="1"/>
           <p:nvPr/>
         </p:nvSpPr>
@@ -12305,7 +12333,7 @@
       </p:sp>
       <p:sp>
         <p:nvSpPr>
-          <p:cNvPr id="195" name="Google Shape;195;p26"/>
+          <p:cNvPr id="196" name="Google Shape;196;p26"/>
           <p:cNvSpPr txBox="1"/>
           <p:nvPr/>
         </p:nvSpPr>
@@ -12368,7 +12396,7 @@
       </p:sp>
       <p:sp>
         <p:nvSpPr>
-          <p:cNvPr id="196" name="Google Shape;196;p26"/>
+          <p:cNvPr id="197" name="Google Shape;197;p26"/>
           <p:cNvSpPr txBox="1"/>
           <p:nvPr/>
         </p:nvSpPr>
@@ -12505,7 +12533,7 @@
       </p:sp>
       <p:pic>
         <p:nvPicPr>
-          <p:cNvPr descr="http://www.duoc.cl/normasgraficas/normasgraficas/marca-duoc/6logo-fondo-transparente/fondo-transparente.png" id="197" name="Google Shape;197;p26"/>
+          <p:cNvPr descr="http://www.duoc.cl/normasgraficas/normasgraficas/marca-duoc/6logo-fondo-transparente/fondo-transparente.png" id="198" name="Google Shape;198;p26"/>
           <p:cNvPicPr preferRelativeResize="0"/>
           <p:nvPr/>
         </p:nvPicPr>
@@ -12544,7 +12572,7 @@
   <p:cSld>
     <p:spTree>
       <p:nvGrpSpPr>
-        <p:cNvPr id="69" name="Shape 69"/>
+        <p:cNvPr id="70" name="Shape 70"/>
         <p:cNvGrpSpPr/>
         <p:nvPr/>
       </p:nvGrpSpPr>
@@ -12558,7 +12586,7 @@
       </p:grpSpPr>
       <p:sp>
         <p:nvSpPr>
-          <p:cNvPr id="70" name="Google Shape;70;p17"/>
+          <p:cNvPr id="71" name="Google Shape;71;p17"/>
           <p:cNvSpPr txBox="1"/>
           <p:nvPr>
             <p:ph type="ctrTitle"/>
@@ -12566,8 +12594,8 @@
         </p:nvSpPr>
         <p:spPr>
           <a:xfrm>
-            <a:off x="311708" y="744575"/>
-            <a:ext cx="8520600" cy="2052600"/>
+            <a:off x="200525" y="-36650"/>
+            <a:ext cx="4290900" cy="792600"/>
           </a:xfrm>
           <a:prstGeom prst="rect">
             <a:avLst/>
@@ -12579,7 +12607,7 @@
         </p:spPr>
         <p:txBody>
           <a:bodyPr anchorCtr="0" anchor="b" bIns="91425" lIns="91425" spcFirstLastPara="1" rIns="91425" wrap="square" tIns="91425">
-            <a:normAutofit/>
+            <a:normAutofit fontScale="90000"/>
           </a:bodyPr>
           <a:lstStyle/>
           <a:p>
@@ -12596,12 +12624,12 @@
               <a:buClr>
                 <a:schemeClr val="dk1"/>
               </a:buClr>
-              <a:buSzPts val="5200"/>
+              <a:buSzPct val="173333"/>
               <a:buFont typeface="Arial"/>
               <a:buNone/>
             </a:pPr>
             <a:r>
-              <a:rPr b="1" lang="es" sz="3900">
+              <a:rPr b="1" lang="es" sz="3000">
                 <a:solidFill>
                   <a:srgbClr val="0F172A"/>
                 </a:solidFill>
@@ -12612,70 +12640,39 @@
               </a:rPr>
               <a:t>Contexto y Descripción</a:t>
             </a:r>
-            <a:endParaRPr/>
+            <a:endParaRPr sz="4300"/>
           </a:p>
         </p:txBody>
       </p:sp>
-      <p:sp>
-        <p:nvSpPr>
-          <p:cNvPr id="71" name="Google Shape;71;p17"/>
-          <p:cNvSpPr txBox="1"/>
-          <p:nvPr>
-            <p:ph idx="1" type="subTitle"/>
-          </p:nvPr>
-        </p:nvSpPr>
+      <p:pic>
+        <p:nvPicPr>
+          <p:cNvPr id="72" name="Google Shape;72;p17"/>
+          <p:cNvPicPr preferRelativeResize="0"/>
+          <p:nvPr/>
+        </p:nvPicPr>
+        <p:blipFill rotWithShape="1">
+          <a:blip r:embed="rId3">
+            <a:alphaModFix/>
+          </a:blip>
+          <a:srcRect b="0" l="448" r="0" t="10722"/>
+          <a:stretch/>
+        </p:blipFill>
         <p:spPr>
           <a:xfrm>
-            <a:off x="311700" y="2834125"/>
-            <a:ext cx="8520600" cy="792600"/>
+            <a:off x="805500" y="667018"/>
+            <a:ext cx="7347000" cy="4478700"/>
           </a:xfrm>
-          <a:prstGeom prst="rect">
-            <a:avLst/>
+          <a:prstGeom prst="round1Rect">
+            <a:avLst>
+              <a:gd fmla="val 16667" name="adj"/>
+            </a:avLst>
           </a:prstGeom>
           <a:noFill/>
           <a:ln>
             <a:noFill/>
           </a:ln>
         </p:spPr>
-        <p:txBody>
-          <a:bodyPr anchorCtr="0" anchor="t" bIns="91425" lIns="91425" spcFirstLastPara="1" rIns="91425" wrap="square" tIns="91425">
-            <a:normAutofit/>
-          </a:bodyPr>
-          <a:lstStyle/>
-          <a:p>
-            <a:pPr indent="0" lvl="0" marL="0" rtl="0" algn="ctr">
-              <a:lnSpc>
-                <a:spcPct val="150000"/>
-              </a:lnSpc>
-              <a:spcBef>
-                <a:spcPts val="0"/>
-              </a:spcBef>
-              <a:spcAft>
-                <a:spcPts val="0"/>
-              </a:spcAft>
-              <a:buClr>
-                <a:schemeClr val="dk1"/>
-              </a:buClr>
-              <a:buSzPts val="2800"/>
-              <a:buFont typeface="Arial"/>
-              <a:buNone/>
-            </a:pPr>
-            <a:r>
-              <a:rPr lang="es" sz="1650">
-                <a:solidFill>
-                  <a:srgbClr val="0284C7"/>
-                </a:solidFill>
-                <a:latin typeface="Inter Medium"/>
-                <a:ea typeface="Inter Medium"/>
-                <a:cs typeface="Inter Medium"/>
-                <a:sym typeface="Inter Medium"/>
-              </a:rPr>
-              <a:t>Problemática operativa real</a:t>
-            </a:r>
-            <a:endParaRPr/>
-          </a:p>
-        </p:txBody>
-      </p:sp>
+      </p:pic>
     </p:spTree>
   </p:cSld>
   <p:clrMapOvr>
@@ -12689,7 +12686,7 @@
   <p:cSld>
     <p:spTree>
       <p:nvGrpSpPr>
-        <p:cNvPr id="75" name="Shape 75"/>
+        <p:cNvPr id="76" name="Shape 76"/>
         <p:cNvGrpSpPr/>
         <p:nvPr/>
       </p:nvGrpSpPr>
@@ -12703,7 +12700,7 @@
       </p:grpSpPr>
       <p:sp>
         <p:nvSpPr>
-          <p:cNvPr id="76" name="Google Shape;76;p18"/>
+          <p:cNvPr id="77" name="Google Shape;77;p18"/>
           <p:cNvSpPr txBox="1"/>
           <p:nvPr/>
         </p:nvSpPr>
@@ -12761,7 +12758,7 @@
       </p:sp>
       <p:sp>
         <p:nvSpPr>
-          <p:cNvPr id="77" name="Google Shape;77;p18"/>
+          <p:cNvPr id="78" name="Google Shape;78;p18"/>
           <p:cNvSpPr txBox="1"/>
           <p:nvPr/>
         </p:nvSpPr>
@@ -12819,7 +12816,7 @@
       </p:sp>
       <p:grpSp>
         <p:nvGrpSpPr>
-          <p:cNvPr id="78" name="Google Shape;78;p18"/>
+          <p:cNvPr id="79" name="Google Shape;79;p18"/>
           <p:cNvGrpSpPr/>
           <p:nvPr/>
         </p:nvGrpSpPr>
@@ -12833,7 +12830,7 @@
         </p:grpSpPr>
         <p:sp>
           <p:nvSpPr>
-            <p:cNvPr id="79" name="Google Shape;79;p18"/>
+            <p:cNvPr id="80" name="Google Shape;80;p18"/>
             <p:cNvSpPr/>
             <p:nvPr/>
           </p:nvSpPr>
@@ -12884,7 +12881,7 @@
         </p:sp>
         <p:sp>
           <p:nvSpPr>
-            <p:cNvPr id="80" name="Google Shape;80;p18"/>
+            <p:cNvPr id="81" name="Google Shape;81;p18"/>
             <p:cNvSpPr/>
             <p:nvPr/>
           </p:nvSpPr>
@@ -12929,7 +12926,7 @@
         </p:sp>
         <p:sp>
           <p:nvSpPr>
-            <p:cNvPr id="81" name="Google Shape;81;p18"/>
+            <p:cNvPr id="82" name="Google Shape;82;p18"/>
             <p:cNvSpPr txBox="1"/>
             <p:nvPr/>
           </p:nvSpPr>
@@ -13099,7 +13096,7 @@
       </p:grpSp>
       <p:grpSp>
         <p:nvGrpSpPr>
-          <p:cNvPr id="82" name="Google Shape;82;p18"/>
+          <p:cNvPr id="83" name="Google Shape;83;p18"/>
           <p:cNvGrpSpPr/>
           <p:nvPr/>
         </p:nvGrpSpPr>
@@ -13113,7 +13110,7 @@
         </p:grpSpPr>
         <p:sp>
           <p:nvSpPr>
-            <p:cNvPr id="83" name="Google Shape;83;p18"/>
+            <p:cNvPr id="84" name="Google Shape;84;p18"/>
             <p:cNvSpPr/>
             <p:nvPr/>
           </p:nvSpPr>
@@ -13164,7 +13161,7 @@
         </p:sp>
         <p:sp>
           <p:nvSpPr>
-            <p:cNvPr id="84" name="Google Shape;84;p18"/>
+            <p:cNvPr id="85" name="Google Shape;85;p18"/>
             <p:cNvSpPr/>
             <p:nvPr/>
           </p:nvSpPr>
@@ -13209,7 +13206,7 @@
         </p:sp>
         <p:sp>
           <p:nvSpPr>
-            <p:cNvPr id="85" name="Google Shape;85;p18"/>
+            <p:cNvPr id="86" name="Google Shape;86;p18"/>
             <p:cNvSpPr txBox="1"/>
             <p:nvPr/>
           </p:nvSpPr>
@@ -13342,7 +13339,7 @@
       </p:grpSp>
       <p:grpSp>
         <p:nvGrpSpPr>
-          <p:cNvPr id="86" name="Google Shape;86;p18"/>
+          <p:cNvPr id="87" name="Google Shape;87;p18"/>
           <p:cNvGrpSpPr/>
           <p:nvPr/>
         </p:nvGrpSpPr>
@@ -13356,7 +13353,7 @@
         </p:grpSpPr>
         <p:sp>
           <p:nvSpPr>
-            <p:cNvPr id="87" name="Google Shape;87;p18"/>
+            <p:cNvPr id="88" name="Google Shape;88;p18"/>
             <p:cNvSpPr/>
             <p:nvPr/>
           </p:nvSpPr>
@@ -13407,7 +13404,7 @@
         </p:sp>
         <p:sp>
           <p:nvSpPr>
-            <p:cNvPr id="88" name="Google Shape;88;p18"/>
+            <p:cNvPr id="89" name="Google Shape;89;p18"/>
             <p:cNvSpPr/>
             <p:nvPr/>
           </p:nvSpPr>
@@ -13452,7 +13449,7 @@
         </p:sp>
         <p:sp>
           <p:nvSpPr>
-            <p:cNvPr id="89" name="Google Shape;89;p18"/>
+            <p:cNvPr id="90" name="Google Shape;90;p18"/>
             <p:cNvSpPr txBox="1"/>
             <p:nvPr/>
           </p:nvSpPr>
@@ -13543,7 +13540,7 @@
       </p:grpSp>
       <p:pic>
         <p:nvPicPr>
-          <p:cNvPr id="90" name="Google Shape;90;p18"/>
+          <p:cNvPr id="91" name="Google Shape;91;p18"/>
           <p:cNvPicPr preferRelativeResize="0"/>
           <p:nvPr/>
         </p:nvPicPr>
@@ -13583,7 +13580,7 @@
   <p:cSld>
     <p:spTree>
       <p:nvGrpSpPr>
-        <p:cNvPr id="94" name="Shape 94"/>
+        <p:cNvPr id="95" name="Shape 95"/>
         <p:cNvGrpSpPr/>
         <p:nvPr/>
       </p:nvGrpSpPr>
@@ -13597,7 +13594,7 @@
       </p:grpSpPr>
       <p:sp>
         <p:nvSpPr>
-          <p:cNvPr id="95" name="Google Shape;95;p19"/>
+          <p:cNvPr id="96" name="Google Shape;96;p19"/>
           <p:cNvSpPr txBox="1"/>
           <p:nvPr/>
         </p:nvSpPr>
@@ -13655,7 +13652,7 @@
       </p:sp>
       <p:grpSp>
         <p:nvGrpSpPr>
-          <p:cNvPr id="96" name="Google Shape;96;p19"/>
+          <p:cNvPr id="97" name="Google Shape;97;p19"/>
           <p:cNvGrpSpPr/>
           <p:nvPr/>
         </p:nvGrpSpPr>
@@ -13669,7 +13666,7 @@
         </p:grpSpPr>
         <p:sp>
           <p:nvSpPr>
-            <p:cNvPr id="97" name="Google Shape;97;p19"/>
+            <p:cNvPr id="98" name="Google Shape;98;p19"/>
             <p:cNvSpPr/>
             <p:nvPr/>
           </p:nvSpPr>
@@ -13720,7 +13717,7 @@
         </p:sp>
         <p:sp>
           <p:nvSpPr>
-            <p:cNvPr id="98" name="Google Shape;98;p19"/>
+            <p:cNvPr id="99" name="Google Shape;99;p19"/>
             <p:cNvSpPr/>
             <p:nvPr/>
           </p:nvSpPr>
@@ -13765,7 +13762,7 @@
         </p:sp>
         <p:sp>
           <p:nvSpPr>
-            <p:cNvPr id="99" name="Google Shape;99;p19"/>
+            <p:cNvPr id="100" name="Google Shape;100;p19"/>
             <p:cNvSpPr txBox="1"/>
             <p:nvPr/>
           </p:nvSpPr>
@@ -13984,7 +13981,7 @@
       </p:grpSp>
       <p:grpSp>
         <p:nvGrpSpPr>
-          <p:cNvPr id="100" name="Google Shape;100;p19"/>
+          <p:cNvPr id="101" name="Google Shape;101;p19"/>
           <p:cNvGrpSpPr/>
           <p:nvPr/>
         </p:nvGrpSpPr>
@@ -13998,7 +13995,7 @@
         </p:grpSpPr>
         <p:sp>
           <p:nvSpPr>
-            <p:cNvPr id="101" name="Google Shape;101;p19"/>
+            <p:cNvPr id="102" name="Google Shape;102;p19"/>
             <p:cNvSpPr/>
             <p:nvPr/>
           </p:nvSpPr>
@@ -14049,7 +14046,7 @@
         </p:sp>
         <p:sp>
           <p:nvSpPr>
-            <p:cNvPr id="102" name="Google Shape;102;p19"/>
+            <p:cNvPr id="103" name="Google Shape;103;p19"/>
             <p:cNvSpPr/>
             <p:nvPr/>
           </p:nvSpPr>
@@ -14094,7 +14091,7 @@
         </p:sp>
         <p:sp>
           <p:nvSpPr>
-            <p:cNvPr id="103" name="Google Shape;103;p19"/>
+            <p:cNvPr id="104" name="Google Shape;104;p19"/>
             <p:cNvSpPr txBox="1"/>
             <p:nvPr/>
           </p:nvSpPr>
@@ -14227,7 +14224,7 @@
       </p:grpSp>
       <p:grpSp>
         <p:nvGrpSpPr>
-          <p:cNvPr id="104" name="Google Shape;104;p19"/>
+          <p:cNvPr id="105" name="Google Shape;105;p19"/>
           <p:cNvGrpSpPr/>
           <p:nvPr/>
         </p:nvGrpSpPr>
@@ -14241,7 +14238,7 @@
         </p:grpSpPr>
         <p:sp>
           <p:nvSpPr>
-            <p:cNvPr id="105" name="Google Shape;105;p19"/>
+            <p:cNvPr id="106" name="Google Shape;106;p19"/>
             <p:cNvSpPr/>
             <p:nvPr/>
           </p:nvSpPr>
@@ -14292,7 +14289,7 @@
         </p:sp>
         <p:sp>
           <p:nvSpPr>
-            <p:cNvPr id="106" name="Google Shape;106;p19"/>
+            <p:cNvPr id="107" name="Google Shape;107;p19"/>
             <p:cNvSpPr/>
             <p:nvPr/>
           </p:nvSpPr>
@@ -14337,7 +14334,7 @@
         </p:sp>
         <p:sp>
           <p:nvSpPr>
-            <p:cNvPr id="107" name="Google Shape;107;p19"/>
+            <p:cNvPr id="108" name="Google Shape;108;p19"/>
             <p:cNvSpPr txBox="1"/>
             <p:nvPr/>
           </p:nvSpPr>
@@ -14507,7 +14504,7 @@
       </p:grpSp>
       <p:grpSp>
         <p:nvGrpSpPr>
-          <p:cNvPr id="108" name="Google Shape;108;p19"/>
+          <p:cNvPr id="109" name="Google Shape;109;p19"/>
           <p:cNvGrpSpPr/>
           <p:nvPr/>
         </p:nvGrpSpPr>
@@ -14521,7 +14518,7 @@
         </p:grpSpPr>
         <p:sp>
           <p:nvSpPr>
-            <p:cNvPr id="109" name="Google Shape;109;p19"/>
+            <p:cNvPr id="110" name="Google Shape;110;p19"/>
             <p:cNvSpPr/>
             <p:nvPr/>
           </p:nvSpPr>
@@ -14572,7 +14569,7 @@
         </p:sp>
         <p:sp>
           <p:nvSpPr>
-            <p:cNvPr id="110" name="Google Shape;110;p19"/>
+            <p:cNvPr id="111" name="Google Shape;111;p19"/>
             <p:cNvSpPr/>
             <p:nvPr/>
           </p:nvSpPr>
@@ -14617,7 +14614,7 @@
         </p:sp>
         <p:sp>
           <p:nvSpPr>
-            <p:cNvPr id="111" name="Google Shape;111;p19"/>
+            <p:cNvPr id="112" name="Google Shape;112;p19"/>
             <p:cNvSpPr txBox="1"/>
             <p:nvPr/>
           </p:nvSpPr>
@@ -14713,7 +14710,7 @@
       </p:grpSp>
       <p:pic>
         <p:nvPicPr>
-          <p:cNvPr descr="image.png" id="112" name="Google Shape;112;p19"/>
+          <p:cNvPr descr="image.png" id="113" name="Google Shape;113;p19"/>
           <p:cNvPicPr preferRelativeResize="0"/>
           <p:nvPr/>
         </p:nvPicPr>
@@ -14740,7 +14737,7 @@
       </p:pic>
       <p:pic>
         <p:nvPicPr>
-          <p:cNvPr descr="image.png" id="113" name="Google Shape;113;p19"/>
+          <p:cNvPr descr="image.png" id="114" name="Google Shape;114;p19"/>
           <p:cNvPicPr preferRelativeResize="0"/>
           <p:nvPr/>
         </p:nvPicPr>
@@ -14767,7 +14764,7 @@
       </p:pic>
       <p:pic>
         <p:nvPicPr>
-          <p:cNvPr descr="image.png" id="114" name="Google Shape;114;p19"/>
+          <p:cNvPr descr="image.png" id="115" name="Google Shape;115;p19"/>
           <p:cNvPicPr preferRelativeResize="0"/>
           <p:nvPr/>
         </p:nvPicPr>
@@ -14794,7 +14791,7 @@
       </p:pic>
       <p:pic>
         <p:nvPicPr>
-          <p:cNvPr descr="image.png" id="115" name="Google Shape;115;p19"/>
+          <p:cNvPr descr="image.png" id="116" name="Google Shape;116;p19"/>
           <p:cNvPicPr preferRelativeResize="0"/>
           <p:nvPr/>
         </p:nvPicPr>
@@ -14821,7 +14818,7 @@
       </p:pic>
       <p:pic>
         <p:nvPicPr>
-          <p:cNvPr descr="image.png" id="116" name="Google Shape;116;p19"/>
+          <p:cNvPr descr="image.png" id="117" name="Google Shape;117;p19"/>
           <p:cNvPicPr preferRelativeResize="0"/>
           <p:nvPr/>
         </p:nvPicPr>
@@ -14848,7 +14845,7 @@
       </p:pic>
       <p:pic>
         <p:nvPicPr>
-          <p:cNvPr descr="image.png" id="117" name="Google Shape;117;p19"/>
+          <p:cNvPr descr="image.png" id="118" name="Google Shape;118;p19"/>
           <p:cNvPicPr preferRelativeResize="0"/>
           <p:nvPr/>
         </p:nvPicPr>
@@ -14875,7 +14872,7 @@
       </p:pic>
       <p:pic>
         <p:nvPicPr>
-          <p:cNvPr descr="image.png" id="118" name="Google Shape;118;p19"/>
+          <p:cNvPr descr="image.png" id="119" name="Google Shape;119;p19"/>
           <p:cNvPicPr preferRelativeResize="0"/>
           <p:nvPr/>
         </p:nvPicPr>
@@ -14902,7 +14899,7 @@
       </p:pic>
       <p:pic>
         <p:nvPicPr>
-          <p:cNvPr descr="image.png" id="119" name="Google Shape;119;p19"/>
+          <p:cNvPr descr="image.png" id="120" name="Google Shape;120;p19"/>
           <p:cNvPicPr preferRelativeResize="0"/>
           <p:nvPr/>
         </p:nvPicPr>
@@ -14940,7 +14937,7 @@
   <p:cSld>
     <p:spTree>
       <p:nvGrpSpPr>
-        <p:cNvPr id="123" name="Shape 123"/>
+        <p:cNvPr id="124" name="Shape 124"/>
         <p:cNvGrpSpPr/>
         <p:nvPr/>
       </p:nvGrpSpPr>
@@ -14954,7 +14951,7 @@
       </p:grpSpPr>
       <p:grpSp>
         <p:nvGrpSpPr>
-          <p:cNvPr id="124" name="Google Shape;124;p20"/>
+          <p:cNvPr id="125" name="Google Shape;125;p20"/>
           <p:cNvGrpSpPr/>
           <p:nvPr/>
         </p:nvGrpSpPr>
@@ -14968,7 +14965,7 @@
         </p:grpSpPr>
         <p:sp>
           <p:nvSpPr>
-            <p:cNvPr id="125" name="Google Shape;125;p20"/>
+            <p:cNvPr id="126" name="Google Shape;126;p20"/>
             <p:cNvSpPr/>
             <p:nvPr/>
           </p:nvSpPr>
@@ -15013,7 +15010,7 @@
         </p:sp>
         <p:sp>
           <p:nvSpPr>
-            <p:cNvPr id="126" name="Google Shape;126;p20"/>
+            <p:cNvPr id="127" name="Google Shape;127;p20"/>
             <p:cNvSpPr txBox="1"/>
             <p:nvPr/>
           </p:nvSpPr>
@@ -15072,7 +15069,7 @@
       </p:grpSp>
       <p:grpSp>
         <p:nvGrpSpPr>
-          <p:cNvPr id="127" name="Google Shape;127;p20"/>
+          <p:cNvPr id="128" name="Google Shape;128;p20"/>
           <p:cNvGrpSpPr/>
           <p:nvPr/>
         </p:nvGrpSpPr>
@@ -15086,7 +15083,7 @@
         </p:grpSpPr>
         <p:sp>
           <p:nvSpPr>
-            <p:cNvPr id="128" name="Google Shape;128;p20"/>
+            <p:cNvPr id="129" name="Google Shape;129;p20"/>
             <p:cNvSpPr/>
             <p:nvPr/>
           </p:nvSpPr>
@@ -15137,7 +15134,7 @@
         </p:sp>
         <p:sp>
           <p:nvSpPr>
-            <p:cNvPr id="129" name="Google Shape;129;p20"/>
+            <p:cNvPr id="130" name="Google Shape;130;p20"/>
             <p:cNvSpPr/>
             <p:nvPr/>
           </p:nvSpPr>
@@ -15182,14 +15179,14 @@
         </p:sp>
         <p:sp>
           <p:nvSpPr>
-            <p:cNvPr id="130" name="Google Shape;130;p20"/>
+            <p:cNvPr id="131" name="Google Shape;131;p20"/>
             <p:cNvSpPr txBox="1"/>
             <p:nvPr/>
           </p:nvSpPr>
           <p:spPr>
             <a:xfrm>
-              <a:off x="238125" y="238125"/>
-              <a:ext cx="3429000" cy="2762400"/>
+              <a:off x="151625" y="238050"/>
+              <a:ext cx="3574500" cy="2762400"/>
             </a:xfrm>
             <a:prstGeom prst="rect">
               <a:avLst/>
@@ -15264,7 +15261,7 @@
                 <a:t>Desarrollar e implementar el sistema A2D SM en arquitectura de 3 capas </a:t>
               </a:r>
               <a:r>
-                <a:rPr b="0" i="1" lang="es" sz="1100">
+                <a:rPr b="1" i="1" lang="es" sz="1100">
                   <a:solidFill>
                     <a:srgbClr val="0284C7"/>
                   </a:solidFill>
@@ -15273,9 +15270,33 @@
                   <a:cs typeface="Inter"/>
                   <a:sym typeface="Inter"/>
                 </a:rPr>
-                <a:t>(React - FastAPI - Base de datos)</a:t>
+                <a:t>(React - FastAPI - </a:t>
               </a:r>
-              <a:endParaRPr b="0" sz="1100">
+              <a:r>
+                <a:rPr b="1" i="1" lang="es" sz="1100">
+                  <a:solidFill>
+                    <a:srgbClr val="0284C7"/>
+                  </a:solidFill>
+                  <a:latin typeface="Inter"/>
+                  <a:ea typeface="Inter"/>
+                  <a:cs typeface="Inter"/>
+                  <a:sym typeface="Inter"/>
+                </a:rPr>
+                <a:t>Base de datos</a:t>
+              </a:r>
+              <a:r>
+                <a:rPr b="1" i="1" lang="es" sz="1100">
+                  <a:solidFill>
+                    <a:srgbClr val="0284C7"/>
+                  </a:solidFill>
+                  <a:latin typeface="Inter"/>
+                  <a:ea typeface="Inter"/>
+                  <a:cs typeface="Inter"/>
+                  <a:sym typeface="Inter"/>
+                </a:rPr>
+                <a:t>)</a:t>
+              </a:r>
+              <a:endParaRPr b="1" sz="1100">
                 <a:solidFill>
                   <a:srgbClr val="475569"/>
                 </a:solidFill>
@@ -15364,7 +15385,7 @@
       </p:grpSp>
       <p:grpSp>
         <p:nvGrpSpPr>
-          <p:cNvPr id="131" name="Google Shape;131;p20"/>
+          <p:cNvPr id="132" name="Google Shape;132;p20"/>
           <p:cNvGrpSpPr/>
           <p:nvPr/>
         </p:nvGrpSpPr>
@@ -15378,7 +15399,7 @@
         </p:grpSpPr>
         <p:sp>
           <p:nvSpPr>
-            <p:cNvPr id="132" name="Google Shape;132;p20"/>
+            <p:cNvPr id="133" name="Google Shape;133;p20"/>
             <p:cNvSpPr/>
             <p:nvPr/>
           </p:nvSpPr>
@@ -15429,7 +15450,7 @@
         </p:sp>
         <p:sp>
           <p:nvSpPr>
-            <p:cNvPr id="133" name="Google Shape;133;p20"/>
+            <p:cNvPr id="134" name="Google Shape;134;p20"/>
             <p:cNvSpPr/>
             <p:nvPr/>
           </p:nvSpPr>
@@ -15474,7 +15495,7 @@
         </p:sp>
         <p:sp>
           <p:nvSpPr>
-            <p:cNvPr id="134" name="Google Shape;134;p20"/>
+            <p:cNvPr id="135" name="Google Shape;135;p20"/>
             <p:cNvSpPr txBox="1"/>
             <p:nvPr/>
           </p:nvSpPr>
@@ -15590,7 +15611,31 @@
                   <a:cs typeface="Inter"/>
                   <a:sym typeface="Inter"/>
                 </a:rPr>
-                <a:t>Implementar un módulo de autenticación y control de acceso basado en roles (RBAC) para restringir el acceso a las funciones operativas del sistema.</a:t>
+                <a:t>Implementar un módulo de autenticación y control de acceso basado en roles </a:t>
+              </a:r>
+              <a:r>
+                <a:rPr b="1" lang="es" sz="1100">
+                  <a:solidFill>
+                    <a:srgbClr val="4A86E8"/>
+                  </a:solidFill>
+                  <a:latin typeface="Inter"/>
+                  <a:ea typeface="Inter"/>
+                  <a:cs typeface="Inter"/>
+                  <a:sym typeface="Inter"/>
+                </a:rPr>
+                <a:t>(RBAC)</a:t>
+              </a:r>
+              <a:r>
+                <a:rPr b="0" lang="es" sz="1100">
+                  <a:solidFill>
+                    <a:srgbClr val="475569"/>
+                  </a:solidFill>
+                  <a:latin typeface="Inter"/>
+                  <a:ea typeface="Inter"/>
+                  <a:cs typeface="Inter"/>
+                  <a:sym typeface="Inter"/>
+                </a:rPr>
+                <a:t> para restringir el acceso a las funciones operativas del sistema.</a:t>
               </a:r>
               <a:endParaRPr b="0" sz="1100">
                 <a:solidFill>
@@ -15618,7 +15663,7 @@
   <p:cSld>
     <p:spTree>
       <p:nvGrpSpPr>
-        <p:cNvPr id="138" name="Shape 138"/>
+        <p:cNvPr id="139" name="Shape 139"/>
         <p:cNvGrpSpPr/>
         <p:nvPr/>
       </p:nvGrpSpPr>
@@ -15632,7 +15677,7 @@
       </p:grpSpPr>
       <p:sp>
         <p:nvSpPr>
-          <p:cNvPr id="139" name="Google Shape;139;p21"/>
+          <p:cNvPr id="140" name="Google Shape;140;p21"/>
           <p:cNvSpPr txBox="1"/>
           <p:nvPr>
             <p:ph type="title"/>
@@ -15692,7 +15737,7 @@
       </p:sp>
       <p:sp>
         <p:nvSpPr>
-          <p:cNvPr id="140" name="Google Shape;140;p21"/>
+          <p:cNvPr id="141" name="Google Shape;141;p21"/>
           <p:cNvSpPr txBox="1"/>
           <p:nvPr/>
         </p:nvSpPr>
@@ -15800,7 +15845,7 @@
   <p:cSld>
     <p:spTree>
       <p:nvGrpSpPr>
-        <p:cNvPr id="144" name="Shape 144"/>
+        <p:cNvPr id="145" name="Shape 145"/>
         <p:cNvGrpSpPr/>
         <p:nvPr/>
       </p:nvGrpSpPr>
@@ -15814,7 +15859,7 @@
       </p:grpSpPr>
       <p:sp>
         <p:nvSpPr>
-          <p:cNvPr id="145" name="Google Shape;145;p22"/>
+          <p:cNvPr id="146" name="Google Shape;146;p22"/>
           <p:cNvSpPr txBox="1"/>
           <p:nvPr>
             <p:ph type="title"/>
@@ -15869,7 +15914,7 @@
       </p:sp>
       <p:grpSp>
         <p:nvGrpSpPr>
-          <p:cNvPr id="146" name="Google Shape;146;p22"/>
+          <p:cNvPr id="147" name="Google Shape;147;p22"/>
           <p:cNvGrpSpPr/>
           <p:nvPr/>
         </p:nvGrpSpPr>
@@ -15883,7 +15928,7 @@
         </p:grpSpPr>
         <p:sp>
           <p:nvSpPr>
-            <p:cNvPr id="147" name="Google Shape;147;p22"/>
+            <p:cNvPr id="148" name="Google Shape;148;p22"/>
             <p:cNvSpPr/>
             <p:nvPr/>
           </p:nvSpPr>
@@ -15934,7 +15979,7 @@
         </p:sp>
         <p:sp>
           <p:nvSpPr>
-            <p:cNvPr id="148" name="Google Shape;148;p22"/>
+            <p:cNvPr id="149" name="Google Shape;149;p22"/>
             <p:cNvSpPr/>
             <p:nvPr/>
           </p:nvSpPr>
@@ -15979,7 +16024,7 @@
         </p:sp>
         <p:sp>
           <p:nvSpPr>
-            <p:cNvPr id="149" name="Google Shape;149;p22"/>
+            <p:cNvPr id="150" name="Google Shape;150;p22"/>
             <p:cNvSpPr txBox="1"/>
             <p:nvPr/>
           </p:nvSpPr>
@@ -16298,7 +16343,7 @@
       </p:grpSp>
       <p:pic>
         <p:nvPicPr>
-          <p:cNvPr id="150" name="Google Shape;150;p22" title="scrum.jpg"/>
+          <p:cNvPr id="151" name="Google Shape;151;p22" title="scrum.jpg"/>
           <p:cNvPicPr preferRelativeResize="0"/>
           <p:nvPr/>
         </p:nvPicPr>
@@ -16336,7 +16381,7 @@
   <p:cSld>
     <p:spTree>
       <p:nvGrpSpPr>
-        <p:cNvPr id="154" name="Shape 154"/>
+        <p:cNvPr id="155" name="Shape 155"/>
         <p:cNvGrpSpPr/>
         <p:nvPr/>
       </p:nvGrpSpPr>
@@ -16350,7 +16395,7 @@
       </p:grpSpPr>
       <p:grpSp>
         <p:nvGrpSpPr>
-          <p:cNvPr id="155" name="Google Shape;155;p23"/>
+          <p:cNvPr id="156" name="Google Shape;156;p23"/>
           <p:cNvGrpSpPr/>
           <p:nvPr/>
         </p:nvGrpSpPr>
@@ -16364,7 +16409,7 @@
         </p:grpSpPr>
         <p:sp>
           <p:nvSpPr>
-            <p:cNvPr id="156" name="Google Shape;156;p23"/>
+            <p:cNvPr id="157" name="Google Shape;157;p23"/>
             <p:cNvSpPr/>
             <p:nvPr/>
           </p:nvSpPr>
@@ -16409,7 +16454,7 @@
         </p:sp>
         <p:sp>
           <p:nvSpPr>
-            <p:cNvPr id="157" name="Google Shape;157;p23"/>
+            <p:cNvPr id="158" name="Google Shape;158;p23"/>
             <p:cNvSpPr txBox="1"/>
             <p:nvPr/>
           </p:nvSpPr>
@@ -16468,7 +16513,7 @@
       </p:grpSp>
       <p:grpSp>
         <p:nvGrpSpPr>
-          <p:cNvPr id="158" name="Google Shape;158;p23"/>
+          <p:cNvPr id="159" name="Google Shape;159;p23"/>
           <p:cNvGrpSpPr/>
           <p:nvPr/>
         </p:nvGrpSpPr>
@@ -16482,7 +16527,7 @@
         </p:grpSpPr>
         <p:sp>
           <p:nvSpPr>
-            <p:cNvPr id="159" name="Google Shape;159;p23"/>
+            <p:cNvPr id="160" name="Google Shape;160;p23"/>
             <p:cNvSpPr/>
             <p:nvPr/>
           </p:nvSpPr>
@@ -16533,7 +16578,7 @@
         </p:sp>
         <p:sp>
           <p:nvSpPr>
-            <p:cNvPr id="160" name="Google Shape;160;p23"/>
+            <p:cNvPr id="161" name="Google Shape;161;p23"/>
             <p:cNvSpPr/>
             <p:nvPr/>
           </p:nvSpPr>
@@ -16578,7 +16623,7 @@
         </p:sp>
         <p:sp>
           <p:nvSpPr>
-            <p:cNvPr id="161" name="Google Shape;161;p23"/>
+            <p:cNvPr id="162" name="Google Shape;162;p23"/>
             <p:cNvSpPr txBox="1"/>
             <p:nvPr/>
           </p:nvSpPr>
@@ -16813,7 +16858,7 @@
       </p:grpSp>
       <p:grpSp>
         <p:nvGrpSpPr>
-          <p:cNvPr id="162" name="Google Shape;162;p23"/>
+          <p:cNvPr id="163" name="Google Shape;163;p23"/>
           <p:cNvGrpSpPr/>
           <p:nvPr/>
         </p:nvGrpSpPr>
@@ -16827,7 +16872,7 @@
         </p:grpSpPr>
         <p:sp>
           <p:nvSpPr>
-            <p:cNvPr id="163" name="Google Shape;163;p23"/>
+            <p:cNvPr id="164" name="Google Shape;164;p23"/>
             <p:cNvSpPr/>
             <p:nvPr/>
           </p:nvSpPr>
@@ -16878,7 +16923,7 @@
         </p:sp>
         <p:sp>
           <p:nvSpPr>
-            <p:cNvPr id="164" name="Google Shape;164;p23"/>
+            <p:cNvPr id="165" name="Google Shape;165;p23"/>
             <p:cNvSpPr/>
             <p:nvPr/>
           </p:nvSpPr>
@@ -16923,7 +16968,7 @@
         </p:sp>
         <p:sp>
           <p:nvSpPr>
-            <p:cNvPr id="165" name="Google Shape;165;p23"/>
+            <p:cNvPr id="166" name="Google Shape;166;p23"/>
             <p:cNvSpPr txBox="1"/>
             <p:nvPr/>
           </p:nvSpPr>
@@ -17113,7 +17158,7 @@
   <p:cSld>
     <p:spTree>
       <p:nvGrpSpPr>
-        <p:cNvPr id="169" name="Shape 169"/>
+        <p:cNvPr id="170" name="Shape 170"/>
         <p:cNvGrpSpPr/>
         <p:nvPr/>
       </p:nvGrpSpPr>
@@ -17127,7 +17172,7 @@
       </p:grpSpPr>
       <p:sp>
         <p:nvSpPr>
-          <p:cNvPr id="170" name="Google Shape;170;p24"/>
+          <p:cNvPr id="171" name="Google Shape;171;p24"/>
           <p:cNvSpPr txBox="1"/>
           <p:nvPr>
             <p:ph type="title"/>
@@ -17187,7 +17232,7 @@
       </p:sp>
       <p:graphicFrame>
         <p:nvGraphicFramePr>
-          <p:cNvPr id="171" name="Google Shape;171;p24"/>
+          <p:cNvPr id="172" name="Google Shape;172;p24"/>
           <p:cNvGraphicFramePr/>
           <p:nvPr/>
         </p:nvGraphicFramePr>
@@ -17200,7 +17245,7 @@
             <a:tbl>
               <a:tblPr>
                 <a:noFill/>
-                <a:tableStyleId>{256C04F7-59DB-40DB-B4D1-DC6EE1E6D764}</a:tableStyleId>
+                <a:tableStyleId>{E605F727-CFD4-4E81-9CF6-A8E1723FF7CF}</a:tableStyleId>
               </a:tblPr>
               <a:tblGrid>
                 <a:gridCol w="2556175"/>
@@ -20207,6 +20252,285 @@
 </file>
 
 <file path=ppt/theme/theme1.xml><?xml version="1.0" encoding="utf-8"?>
+<a:theme xmlns:a="http://schemas.openxmlformats.org/drawingml/2006/main" xmlns:r="http://schemas.openxmlformats.org/officeDocument/2006/relationships" name="Office Theme">
+  <a:themeElements>
+    <a:clrScheme name="Office">
+      <a:dk1>
+        <a:srgbClr val="000000"/>
+      </a:dk1>
+      <a:lt1>
+        <a:srgbClr val="FFFFFF"/>
+      </a:lt1>
+      <a:dk2>
+        <a:srgbClr val="44546A"/>
+      </a:dk2>
+      <a:lt2>
+        <a:srgbClr val="E7E6E6"/>
+      </a:lt2>
+      <a:accent1>
+        <a:srgbClr val="4472C4"/>
+      </a:accent1>
+      <a:accent2>
+        <a:srgbClr val="ED7D31"/>
+      </a:accent2>
+      <a:accent3>
+        <a:srgbClr val="A5A5A5"/>
+      </a:accent3>
+      <a:accent4>
+        <a:srgbClr val="FFC000"/>
+      </a:accent4>
+      <a:accent5>
+        <a:srgbClr val="5B9BD5"/>
+      </a:accent5>
+      <a:accent6>
+        <a:srgbClr val="70AD47"/>
+      </a:accent6>
+      <a:hlink>
+        <a:srgbClr val="0563C1"/>
+      </a:hlink>
+      <a:folHlink>
+        <a:srgbClr val="954F72"/>
+      </a:folHlink>
+    </a:clrScheme>
+    <a:fontScheme name="Office">
+      <a:majorFont>
+        <a:latin typeface="Arial"/>
+        <a:ea typeface=""/>
+        <a:cs typeface=""/>
+        <a:font script="Jpan" typeface="ＭＳ Ｐゴシック"/>
+        <a:font script="Hang" typeface="맑은 고딕"/>
+        <a:font script="Hans" typeface="宋体"/>
+        <a:font script="Hant" typeface="新細明體"/>
+        <a:font script="Arab" typeface="Times New Roman"/>
+        <a:font script="Hebr" typeface="Times New Roman"/>
+        <a:font script="Thai" typeface="Angsana New"/>
+        <a:font script="Ethi" typeface="Nyala"/>
+        <a:font script="Beng" typeface="Vrinda"/>
+        <a:font script="Gujr" typeface="Shruti"/>
+        <a:font script="Khmr" typeface="MoolBoran"/>
+        <a:font script="Knda" typeface="Tunga"/>
+        <a:font script="Guru" typeface="Raavi"/>
+        <a:font script="Cans" typeface="Euphemia"/>
+        <a:font script="Cher" typeface="Plantagenet Cherokee"/>
+        <a:font script="Yiii" typeface="Microsoft Yi Baiti"/>
+        <a:font script="Tibt" typeface="Microsoft Himalaya"/>
+        <a:font script="Thaa" typeface="MV Boli"/>
+        <a:font script="Deva" typeface="Mangal"/>
+        <a:font script="Telu" typeface="Gautami"/>
+        <a:font script="Taml" typeface="Latha"/>
+        <a:font script="Syrc" typeface="Estrangelo Edessa"/>
+        <a:font script="Orya" typeface="Kalinga"/>
+        <a:font script="Mlym" typeface="Kartika"/>
+        <a:font script="Laoo" typeface="DokChampa"/>
+        <a:font script="Sinh" typeface="Iskoola Pota"/>
+        <a:font script="Mong" typeface="Mongolian Baiti"/>
+        <a:font script="Viet" typeface="Times New Roman"/>
+        <a:font script="Uigh" typeface="Microsoft Uighur"/>
+        <a:font script="Geor" typeface="Sylfaen"/>
+      </a:majorFont>
+      <a:minorFont>
+        <a:latin typeface="Arial"/>
+        <a:ea typeface=""/>
+        <a:cs typeface=""/>
+        <a:font script="Jpan" typeface="ＭＳ Ｐゴシック"/>
+        <a:font script="Hang" typeface="맑은 고딕"/>
+        <a:font script="Hans" typeface="宋体"/>
+        <a:font script="Hant" typeface="新細明體"/>
+        <a:font script="Arab" typeface="Arial"/>
+        <a:font script="Hebr" typeface="Arial"/>
+        <a:font script="Thai" typeface="Cordia New"/>
+        <a:font script="Ethi" typeface="Nyala"/>
+        <a:font script="Beng" typeface="Vrinda"/>
+        <a:font script="Gujr" typeface="Shruti"/>
+        <a:font script="Khmr" typeface="DaunPenh"/>
+        <a:font script="Knda" typeface="Tunga"/>
+        <a:font script="Guru" typeface="Raavi"/>
+        <a:font script="Cans" typeface="Euphemia"/>
+        <a:font script="Cher" typeface="Plantagenet Cherokee"/>
+        <a:font script="Yiii" typeface="Microsoft Yi Baiti"/>
+        <a:font script="Tibt" typeface="Microsoft Himalaya"/>
+        <a:font script="Thaa" typeface="MV Boli"/>
+        <a:font script="Deva" typeface="Mangal"/>
+        <a:font script="Telu" typeface="Gautami"/>
+        <a:font script="Taml" typeface="Latha"/>
+        <a:font script="Syrc" typeface="Estrangelo Edessa"/>
+        <a:font script="Orya" typeface="Kalinga"/>
+        <a:font script="Mlym" typeface="Kartika"/>
+        <a:font script="Laoo" typeface="DokChampa"/>
+        <a:font script="Sinh" typeface="Iskoola Pota"/>
+        <a:font script="Mong" typeface="Mongolian Baiti"/>
+        <a:font script="Viet" typeface="Arial"/>
+        <a:font script="Uigh" typeface="Microsoft Uighur"/>
+        <a:font script="Geor" typeface="Sylfaen"/>
+      </a:minorFont>
+    </a:fontScheme>
+    <a:fmtScheme name="Office">
+      <a:fillStyleLst>
+        <a:solidFill>
+          <a:schemeClr val="phClr"/>
+        </a:solidFill>
+        <a:gradFill rotWithShape="1">
+          <a:gsLst>
+            <a:gs pos="0">
+              <a:schemeClr val="phClr">
+                <a:tint val="50000"/>
+                <a:satMod val="300000"/>
+              </a:schemeClr>
+            </a:gs>
+            <a:gs pos="35000">
+              <a:schemeClr val="phClr">
+                <a:tint val="37000"/>
+                <a:satMod val="300000"/>
+              </a:schemeClr>
+            </a:gs>
+            <a:gs pos="100000">
+              <a:schemeClr val="phClr">
+                <a:tint val="15000"/>
+                <a:satMod val="350000"/>
+              </a:schemeClr>
+            </a:gs>
+          </a:gsLst>
+          <a:lin ang="16200000" scaled="1"/>
+        </a:gradFill>
+        <a:gradFill rotWithShape="1">
+          <a:gsLst>
+            <a:gs pos="0">
+              <a:schemeClr val="phClr">
+                <a:tint val="100000"/>
+                <a:shade val="100000"/>
+                <a:satMod val="130000"/>
+              </a:schemeClr>
+            </a:gs>
+            <a:gs pos="100000">
+              <a:schemeClr val="phClr">
+                <a:tint val="50000"/>
+                <a:shade val="100000"/>
+                <a:satMod val="350000"/>
+              </a:schemeClr>
+            </a:gs>
+          </a:gsLst>
+          <a:lin ang="16200000" scaled="0"/>
+        </a:gradFill>
+      </a:fillStyleLst>
+      <a:lnStyleLst>
+        <a:ln w="9525" cap="flat" cmpd="sng" algn="ctr">
+          <a:solidFill>
+            <a:schemeClr val="phClr">
+              <a:shade val="95000"/>
+              <a:satMod val="105000"/>
+            </a:schemeClr>
+          </a:solidFill>
+          <a:prstDash val="solid"/>
+        </a:ln>
+        <a:ln w="25400" cap="flat" cmpd="sng" algn="ctr">
+          <a:solidFill>
+            <a:schemeClr val="phClr"/>
+          </a:solidFill>
+          <a:prstDash val="solid"/>
+        </a:ln>
+        <a:ln w="38100" cap="flat" cmpd="sng" algn="ctr">
+          <a:solidFill>
+            <a:schemeClr val="phClr"/>
+          </a:solidFill>
+          <a:prstDash val="solid"/>
+        </a:ln>
+      </a:lnStyleLst>
+      <a:effectStyleLst>
+        <a:effectStyle>
+          <a:effectLst>
+            <a:outerShdw blurRad="40000" dist="20000" dir="5400000" rotWithShape="0">
+              <a:srgbClr val="000000">
+                <a:alpha val="38000"/>
+              </a:srgbClr>
+            </a:outerShdw>
+          </a:effectLst>
+        </a:effectStyle>
+        <a:effectStyle>
+          <a:effectLst>
+            <a:outerShdw blurRad="40000" dist="23000" dir="5400000" rotWithShape="0">
+              <a:srgbClr val="000000">
+                <a:alpha val="35000"/>
+              </a:srgbClr>
+            </a:outerShdw>
+          </a:effectLst>
+        </a:effectStyle>
+        <a:effectStyle>
+          <a:effectLst>
+            <a:outerShdw blurRad="40000" dist="23000" dir="5400000" rotWithShape="0">
+              <a:srgbClr val="000000">
+                <a:alpha val="35000"/>
+              </a:srgbClr>
+            </a:outerShdw>
+          </a:effectLst>
+          <a:scene3d>
+            <a:camera prst="orthographicFront">
+              <a:rot lat="0" lon="0" rev="0"/>
+            </a:camera>
+            <a:lightRig rig="threePt" dir="t">
+              <a:rot lat="0" lon="0" rev="1200000"/>
+            </a:lightRig>
+          </a:scene3d>
+          <a:sp3d>
+            <a:bevelT w="63500" h="25400"/>
+          </a:sp3d>
+        </a:effectStyle>
+      </a:effectStyleLst>
+      <a:bgFillStyleLst>
+        <a:solidFill>
+          <a:schemeClr val="phClr"/>
+        </a:solidFill>
+        <a:gradFill rotWithShape="1">
+          <a:gsLst>
+            <a:gs pos="0">
+              <a:schemeClr val="phClr">
+                <a:tint val="40000"/>
+                <a:satMod val="350000"/>
+              </a:schemeClr>
+            </a:gs>
+            <a:gs pos="40000">
+              <a:schemeClr val="phClr">
+                <a:tint val="45000"/>
+                <a:shade val="99000"/>
+                <a:satMod val="350000"/>
+              </a:schemeClr>
+            </a:gs>
+            <a:gs pos="100000">
+              <a:schemeClr val="phClr">
+                <a:shade val="20000"/>
+                <a:satMod val="255000"/>
+              </a:schemeClr>
+            </a:gs>
+          </a:gsLst>
+          <a:path path="circle">
+            <a:fillToRect l="50000" t="-80000" r="50000" b="180000"/>
+          </a:path>
+        </a:gradFill>
+        <a:gradFill rotWithShape="1">
+          <a:gsLst>
+            <a:gs pos="0">
+              <a:schemeClr val="phClr">
+                <a:tint val="80000"/>
+                <a:satMod val="300000"/>
+              </a:schemeClr>
+            </a:gs>
+            <a:gs pos="100000">
+              <a:schemeClr val="phClr">
+                <a:shade val="30000"/>
+                <a:satMod val="200000"/>
+              </a:schemeClr>
+            </a:gs>
+          </a:gsLst>
+          <a:path path="circle">
+            <a:fillToRect l="50000" t="50000" r="50000" b="50000"/>
+          </a:path>
+        </a:gradFill>
+      </a:bgFillStyleLst>
+    </a:fmtScheme>
+  </a:themeElements>
+</a:theme>
+</file>
+
+<file path=ppt/theme/theme2.xml><?xml version="1.0" encoding="utf-8"?>
 <a:theme xmlns:a="http://schemas.openxmlformats.org/drawingml/2006/main" xmlns:r="http://schemas.openxmlformats.org/officeDocument/2006/relationships" name="Simple Light">
   <a:themeElements>
     <a:clrScheme name="Simple Light">
@@ -20485,7 +20809,7 @@
 </a:theme>
 </file>
 
-<file path=ppt/theme/theme2.xml><?xml version="1.0" encoding="utf-8"?>
+<file path=ppt/theme/theme3.xml><?xml version="1.0" encoding="utf-8"?>
 <a:theme xmlns:a="http://schemas.openxmlformats.org/drawingml/2006/main" xmlns:r="http://schemas.openxmlformats.org/officeDocument/2006/relationships">
   <a:themeElements>
     <a:clrScheme name="Default">
@@ -20762,283 +21086,4 @@
     </a:fmtScheme>
   </a:themeElements>
 </a:theme>
-</file>
-
-<file path=ppt/theme/theme3.xml><?xml version="1.0" encoding="utf-8"?>
-<a:theme xmlns:a="http://schemas.openxmlformats.org/drawingml/2006/main" xmlns:r="http://schemas.openxmlformats.org/officeDocument/2006/relationships" name="Office Theme">
-  <a:themeElements>
-    <a:clrScheme name="Office">
-      <a:dk1>
-        <a:srgbClr val="000000"/>
-      </a:dk1>
-      <a:lt1>
-        <a:srgbClr val="FFFFFF"/>
-      </a:lt1>
-      <a:dk2>
-        <a:srgbClr val="44546A"/>
-      </a:dk2>
-      <a:lt2>
-        <a:srgbClr val="E7E6E6"/>
-      </a:lt2>
-      <a:accent1>
-        <a:srgbClr val="4472C4"/>
-      </a:accent1>
-      <a:accent2>
-        <a:srgbClr val="ED7D31"/>
-      </a:accent2>
-      <a:accent3>
-        <a:srgbClr val="A5A5A5"/>
-      </a:accent3>
-      <a:accent4>
-        <a:srgbClr val="FFC000"/>
-      </a:accent4>
-      <a:accent5>
-        <a:srgbClr val="5B9BD5"/>
-      </a:accent5>
-      <a:accent6>
-        <a:srgbClr val="70AD47"/>
-      </a:accent6>
-      <a:hlink>
-        <a:srgbClr val="0563C1"/>
-      </a:hlink>
-      <a:folHlink>
-        <a:srgbClr val="954F72"/>
-      </a:folHlink>
-    </a:clrScheme>
-    <a:fontScheme name="Office">
-      <a:majorFont>
-        <a:latin typeface="Arial"/>
-        <a:ea typeface=""/>
-        <a:cs typeface=""/>
-        <a:font script="Jpan" typeface="ＭＳ Ｐゴシック"/>
-        <a:font script="Hang" typeface="맑은 고딕"/>
-        <a:font script="Hans" typeface="宋体"/>
-        <a:font script="Hant" typeface="新細明體"/>
-        <a:font script="Arab" typeface="Times New Roman"/>
-        <a:font script="Hebr" typeface="Times New Roman"/>
-        <a:font script="Thai" typeface="Angsana New"/>
-        <a:font script="Ethi" typeface="Nyala"/>
-        <a:font script="Beng" typeface="Vrinda"/>
-        <a:font script="Gujr" typeface="Shruti"/>
-        <a:font script="Khmr" typeface="MoolBoran"/>
-        <a:font script="Knda" typeface="Tunga"/>
-        <a:font script="Guru" typeface="Raavi"/>
-        <a:font script="Cans" typeface="Euphemia"/>
-        <a:font script="Cher" typeface="Plantagenet Cherokee"/>
-        <a:font script="Yiii" typeface="Microsoft Yi Baiti"/>
-        <a:font script="Tibt" typeface="Microsoft Himalaya"/>
-        <a:font script="Thaa" typeface="MV Boli"/>
-        <a:font script="Deva" typeface="Mangal"/>
-        <a:font script="Telu" typeface="Gautami"/>
-        <a:font script="Taml" typeface="Latha"/>
-        <a:font script="Syrc" typeface="Estrangelo Edessa"/>
-        <a:font script="Orya" typeface="Kalinga"/>
-        <a:font script="Mlym" typeface="Kartika"/>
-        <a:font script="Laoo" typeface="DokChampa"/>
-        <a:font script="Sinh" typeface="Iskoola Pota"/>
-        <a:font script="Mong" typeface="Mongolian Baiti"/>
-        <a:font script="Viet" typeface="Times New Roman"/>
-        <a:font script="Uigh" typeface="Microsoft Uighur"/>
-        <a:font script="Geor" typeface="Sylfaen"/>
-      </a:majorFont>
-      <a:minorFont>
-        <a:latin typeface="Arial"/>
-        <a:ea typeface=""/>
-        <a:cs typeface=""/>
-        <a:font script="Jpan" typeface="ＭＳ Ｐゴシック"/>
-        <a:font script="Hang" typeface="맑은 고딕"/>
-        <a:font script="Hans" typeface="宋体"/>
-        <a:font script="Hant" typeface="新細明體"/>
-        <a:font script="Arab" typeface="Arial"/>
-        <a:font script="Hebr" typeface="Arial"/>
-        <a:font script="Thai" typeface="Cordia New"/>
-        <a:font script="Ethi" typeface="Nyala"/>
-        <a:font script="Beng" typeface="Vrinda"/>
-        <a:font script="Gujr" typeface="Shruti"/>
-        <a:font script="Khmr" typeface="DaunPenh"/>
-        <a:font script="Knda" typeface="Tunga"/>
-        <a:font script="Guru" typeface="Raavi"/>
-        <a:font script="Cans" typeface="Euphemia"/>
-        <a:font script="Cher" typeface="Plantagenet Cherokee"/>
-        <a:font script="Yiii" typeface="Microsoft Yi Baiti"/>
-        <a:font script="Tibt" typeface="Microsoft Himalaya"/>
-        <a:font script="Thaa" typeface="MV Boli"/>
-        <a:font script="Deva" typeface="Mangal"/>
-        <a:font script="Telu" typeface="Gautami"/>
-        <a:font script="Taml" typeface="Latha"/>
-        <a:font script="Syrc" typeface="Estrangelo Edessa"/>
-        <a:font script="Orya" typeface="Kalinga"/>
-        <a:font script="Mlym" typeface="Kartika"/>
-        <a:font script="Laoo" typeface="DokChampa"/>
-        <a:font script="Sinh" typeface="Iskoola Pota"/>
-        <a:font script="Mong" typeface="Mongolian Baiti"/>
-        <a:font script="Viet" typeface="Arial"/>
-        <a:font script="Uigh" typeface="Microsoft Uighur"/>
-        <a:font script="Geor" typeface="Sylfaen"/>
-      </a:minorFont>
-    </a:fontScheme>
-    <a:fmtScheme name="Office">
-      <a:fillStyleLst>
-        <a:solidFill>
-          <a:schemeClr val="phClr"/>
-        </a:solidFill>
-        <a:gradFill rotWithShape="1">
-          <a:gsLst>
-            <a:gs pos="0">
-              <a:schemeClr val="phClr">
-                <a:tint val="50000"/>
-                <a:satMod val="300000"/>
-              </a:schemeClr>
-            </a:gs>
-            <a:gs pos="35000">
-              <a:schemeClr val="phClr">
-                <a:tint val="37000"/>
-                <a:satMod val="300000"/>
-              </a:schemeClr>
-            </a:gs>
-            <a:gs pos="100000">
-              <a:schemeClr val="phClr">
-                <a:tint val="15000"/>
-                <a:satMod val="350000"/>
-              </a:schemeClr>
-            </a:gs>
-          </a:gsLst>
-          <a:lin ang="16200000" scaled="1"/>
-        </a:gradFill>
-        <a:gradFill rotWithShape="1">
-          <a:gsLst>
-            <a:gs pos="0">
-              <a:schemeClr val="phClr">
-                <a:tint val="100000"/>
-                <a:shade val="100000"/>
-                <a:satMod val="130000"/>
-              </a:schemeClr>
-            </a:gs>
-            <a:gs pos="100000">
-              <a:schemeClr val="phClr">
-                <a:tint val="50000"/>
-                <a:shade val="100000"/>
-                <a:satMod val="350000"/>
-              </a:schemeClr>
-            </a:gs>
-          </a:gsLst>
-          <a:lin ang="16200000" scaled="0"/>
-        </a:gradFill>
-      </a:fillStyleLst>
-      <a:lnStyleLst>
-        <a:ln w="9525" cap="flat" cmpd="sng" algn="ctr">
-          <a:solidFill>
-            <a:schemeClr val="phClr">
-              <a:shade val="95000"/>
-              <a:satMod val="105000"/>
-            </a:schemeClr>
-          </a:solidFill>
-          <a:prstDash val="solid"/>
-        </a:ln>
-        <a:ln w="25400" cap="flat" cmpd="sng" algn="ctr">
-          <a:solidFill>
-            <a:schemeClr val="phClr"/>
-          </a:solidFill>
-          <a:prstDash val="solid"/>
-        </a:ln>
-        <a:ln w="38100" cap="flat" cmpd="sng" algn="ctr">
-          <a:solidFill>
-            <a:schemeClr val="phClr"/>
-          </a:solidFill>
-          <a:prstDash val="solid"/>
-        </a:ln>
-      </a:lnStyleLst>
-      <a:effectStyleLst>
-        <a:effectStyle>
-          <a:effectLst>
-            <a:outerShdw blurRad="40000" dist="20000" dir="5400000" rotWithShape="0">
-              <a:srgbClr val="000000">
-                <a:alpha val="38000"/>
-              </a:srgbClr>
-            </a:outerShdw>
-          </a:effectLst>
-        </a:effectStyle>
-        <a:effectStyle>
-          <a:effectLst>
-            <a:outerShdw blurRad="40000" dist="23000" dir="5400000" rotWithShape="0">
-              <a:srgbClr val="000000">
-                <a:alpha val="35000"/>
-              </a:srgbClr>
-            </a:outerShdw>
-          </a:effectLst>
-        </a:effectStyle>
-        <a:effectStyle>
-          <a:effectLst>
-            <a:outerShdw blurRad="40000" dist="23000" dir="5400000" rotWithShape="0">
-              <a:srgbClr val="000000">
-                <a:alpha val="35000"/>
-              </a:srgbClr>
-            </a:outerShdw>
-          </a:effectLst>
-          <a:scene3d>
-            <a:camera prst="orthographicFront">
-              <a:rot lat="0" lon="0" rev="0"/>
-            </a:camera>
-            <a:lightRig rig="threePt" dir="t">
-              <a:rot lat="0" lon="0" rev="1200000"/>
-            </a:lightRig>
-          </a:scene3d>
-          <a:sp3d>
-            <a:bevelT w="63500" h="25400"/>
-          </a:sp3d>
-        </a:effectStyle>
-      </a:effectStyleLst>
-      <a:bgFillStyleLst>
-        <a:solidFill>
-          <a:schemeClr val="phClr"/>
-        </a:solidFill>
-        <a:gradFill rotWithShape="1">
-          <a:gsLst>
-            <a:gs pos="0">
-              <a:schemeClr val="phClr">
-                <a:tint val="40000"/>
-                <a:satMod val="350000"/>
-              </a:schemeClr>
-            </a:gs>
-            <a:gs pos="40000">
-              <a:schemeClr val="phClr">
-                <a:tint val="45000"/>
-                <a:shade val="99000"/>
-                <a:satMod val="350000"/>
-              </a:schemeClr>
-            </a:gs>
-            <a:gs pos="100000">
-              <a:schemeClr val="phClr">
-                <a:shade val="20000"/>
-                <a:satMod val="255000"/>
-              </a:schemeClr>
-            </a:gs>
-          </a:gsLst>
-          <a:path path="circle">
-            <a:fillToRect l="50000" t="-80000" r="50000" b="180000"/>
-          </a:path>
-        </a:gradFill>
-        <a:gradFill rotWithShape="1">
-          <a:gsLst>
-            <a:gs pos="0">
-              <a:schemeClr val="phClr">
-                <a:tint val="80000"/>
-                <a:satMod val="300000"/>
-              </a:schemeClr>
-            </a:gs>
-            <a:gs pos="100000">
-              <a:schemeClr val="phClr">
-                <a:shade val="30000"/>
-                <a:satMod val="200000"/>
-              </a:schemeClr>
-            </a:gs>
-          </a:gsLst>
-          <a:path path="circle">
-            <a:fillToRect l="50000" t="50000" r="50000" b="50000"/>
-          </a:path>
-        </a:gradFill>
-      </a:bgFillStyleLst>
-    </a:fmtScheme>
-  </a:themeElements>
-</a:theme>
 </file>
</xml_diff>